<commit_message>
Release v0.5.0: slide fixes and Your Environment at slide 12
- Current State lists the pain points after the current-state lines; commas and semicolons split items into separate bullets, with shrink-to-fit past ten.
- Your Environment (formerly Inventory Recap) moves to slide 12, after Current State.
- Pricing slide "/ month" sits below the monthly figure instead of overlapping it.
- Rates slide stray divider lines and check marks removed.
- Closing slide shrinks long client names so they stay clear of "Thank you,".
- prepare_templates.py applies the layout corrections to template and reference deck.

Co-Authored-By: Claude Fable 5.1 <noreply@anthropic.com>
Claude-Session: https://claude.ai/code/session_01G8P7ncf4uPEYvEUgb9vNpS
</commit_message>
<xml_diff>
--- a/templates/proposal.pptx
+++ b/templates/proposal.pptx
@@ -4240,8 +4240,8 @@
         </p:nvSpPr>
         <p:spPr>
           <a:xfrm>
-            <a:off x="3038668" y="1953137"/>
-            <a:ext cx="3383280" cy="365760"/>
+            <a:off x="3038668" y="2331720"/>
+            <a:ext cx="3383280" cy="274320"/>
           </a:xfrm>
           <a:prstGeom prst="rect">
             <a:avLst/>
@@ -9149,225 +9149,6 @@
           </a:p>
         </p:txBody>
       </p:sp>
-      <p:sp>
-        <p:nvSpPr>
-          <p:cNvPr id="26" name="Shape 22"/>
-          <p:cNvSpPr/>
-          <p:nvPr/>
-        </p:nvSpPr>
-        <p:spPr>
-          <a:xfrm>
-            <a:off x="2496312" y="3474720"/>
-            <a:ext cx="9144" cy="868680"/>
-          </a:xfrm>
-          <a:prstGeom prst="rect">
-            <a:avLst/>
-          </a:prstGeom>
-          <a:solidFill>
-            <a:srgbClr val="E2E8F0"/>
-          </a:solidFill>
-          <a:ln/>
-        </p:spPr>
-        <p:txBody>
-          <a:bodyPr/>
-          <a:lstStyle/>
-          <a:p>
-            <a:pPr marL="0" marR="0" lvl="0" indent="0" algn="l" defTabSz="914400" rtl="0" eaLnBrk="1" fontAlgn="auto" latinLnBrk="0" hangingPunct="1">
-              <a:lnSpc>
-                <a:spcPct val="100000"/>
-              </a:lnSpc>
-              <a:spcBef>
-                <a:spcPts val="0"/>
-              </a:spcBef>
-              <a:spcAft>
-                <a:spcPts val="0"/>
-              </a:spcAft>
-              <a:buClrTx/>
-              <a:buSzTx/>
-              <a:buFontTx/>
-              <a:buNone/>
-              <a:tabLst/>
-              <a:defRPr/>
-            </a:pPr>
-            <a:endParaRPr kumimoji="0" lang="en-US" sz="1800" b="0" i="0" u="none" strike="noStrike" kern="1200" cap="none" spc="0" normalizeH="0" baseline="0" noProof="0">
-              <a:ln>
-                <a:noFill/>
-              </a:ln>
-              <a:solidFill>
-                <a:prstClr val="black"/>
-              </a:solidFill>
-              <a:effectLst/>
-              <a:uLnTx/>
-              <a:uFillTx/>
-              <a:latin typeface="Calibri" panose="020F0502020204030204"/>
-              <a:ea typeface="+mn-ea"/>
-              <a:cs typeface="+mn-cs"/>
-            </a:endParaRPr>
-          </a:p>
-        </p:txBody>
-      </p:sp>
-      <p:pic>
-        <p:nvPicPr>
-          <p:cNvPr id="28" name="Image 2" descr="preencoded.png"/>
-          <p:cNvPicPr>
-            <a:picLocks noChangeAspect="1"/>
-          </p:cNvPicPr>
-          <p:nvPr/>
-        </p:nvPicPr>
-        <p:blipFill>
-          <a:blip r:embed="rId4"/>
-          <a:stretch>
-            <a:fillRect/>
-          </a:stretch>
-        </p:blipFill>
-        <p:spPr>
-          <a:xfrm>
-            <a:off x="2610612" y="3461004"/>
-            <a:ext cx="164592" cy="164592"/>
-          </a:xfrm>
-          <a:prstGeom prst="rect">
-            <a:avLst/>
-          </a:prstGeom>
-        </p:spPr>
-      </p:pic>
-      <p:sp>
-        <p:nvSpPr>
-          <p:cNvPr id="31" name="Shape 26"/>
-          <p:cNvSpPr/>
-          <p:nvPr/>
-        </p:nvSpPr>
-        <p:spPr>
-          <a:xfrm>
-            <a:off x="4572000" y="3474720"/>
-            <a:ext cx="9144" cy="868680"/>
-          </a:xfrm>
-          <a:prstGeom prst="rect">
-            <a:avLst/>
-          </a:prstGeom>
-          <a:solidFill>
-            <a:srgbClr val="E2E8F0"/>
-          </a:solidFill>
-          <a:ln/>
-        </p:spPr>
-        <p:txBody>
-          <a:bodyPr/>
-          <a:lstStyle/>
-          <a:p>
-            <a:pPr marL="0" marR="0" lvl="0" indent="0" algn="l" defTabSz="914400" rtl="0" eaLnBrk="1" fontAlgn="auto" latinLnBrk="0" hangingPunct="1">
-              <a:lnSpc>
-                <a:spcPct val="100000"/>
-              </a:lnSpc>
-              <a:spcBef>
-                <a:spcPts val="0"/>
-              </a:spcBef>
-              <a:spcAft>
-                <a:spcPts val="0"/>
-              </a:spcAft>
-              <a:buClrTx/>
-              <a:buSzTx/>
-              <a:buFontTx/>
-              <a:buNone/>
-              <a:tabLst/>
-              <a:defRPr/>
-            </a:pPr>
-            <a:endParaRPr kumimoji="0" lang="en-US" sz="1800" b="0" i="0" u="none" strike="noStrike" kern="1200" cap="none" spc="0" normalizeH="0" baseline="0" noProof="0">
-              <a:ln>
-                <a:noFill/>
-              </a:ln>
-              <a:solidFill>
-                <a:prstClr val="black"/>
-              </a:solidFill>
-              <a:effectLst/>
-              <a:uLnTx/>
-              <a:uFillTx/>
-              <a:latin typeface="Calibri" panose="020F0502020204030204"/>
-              <a:ea typeface="+mn-ea"/>
-              <a:cs typeface="+mn-cs"/>
-            </a:endParaRPr>
-          </a:p>
-        </p:txBody>
-      </p:sp>
-      <p:sp>
-        <p:nvSpPr>
-          <p:cNvPr id="36" name="Shape 30"/>
-          <p:cNvSpPr/>
-          <p:nvPr/>
-        </p:nvSpPr>
-        <p:spPr>
-          <a:xfrm>
-            <a:off x="6647688" y="3474720"/>
-            <a:ext cx="9144" cy="868680"/>
-          </a:xfrm>
-          <a:prstGeom prst="rect">
-            <a:avLst/>
-          </a:prstGeom>
-          <a:solidFill>
-            <a:srgbClr val="E2E8F0"/>
-          </a:solidFill>
-          <a:ln/>
-        </p:spPr>
-        <p:txBody>
-          <a:bodyPr/>
-          <a:lstStyle/>
-          <a:p>
-            <a:pPr marL="0" marR="0" lvl="0" indent="0" algn="l" defTabSz="914400" rtl="0" eaLnBrk="1" fontAlgn="auto" latinLnBrk="0" hangingPunct="1">
-              <a:lnSpc>
-                <a:spcPct val="100000"/>
-              </a:lnSpc>
-              <a:spcBef>
-                <a:spcPts val="0"/>
-              </a:spcBef>
-              <a:spcAft>
-                <a:spcPts val="0"/>
-              </a:spcAft>
-              <a:buClrTx/>
-              <a:buSzTx/>
-              <a:buFontTx/>
-              <a:buNone/>
-              <a:tabLst/>
-              <a:defRPr/>
-            </a:pPr>
-            <a:endParaRPr kumimoji="0" lang="en-US" sz="1800" b="0" i="0" u="none" strike="noStrike" kern="1200" cap="none" spc="0" normalizeH="0" baseline="0" noProof="0">
-              <a:ln>
-                <a:noFill/>
-              </a:ln>
-              <a:solidFill>
-                <a:prstClr val="black"/>
-              </a:solidFill>
-              <a:effectLst/>
-              <a:uLnTx/>
-              <a:uFillTx/>
-              <a:latin typeface="Calibri" panose="020F0502020204030204"/>
-              <a:ea typeface="+mn-ea"/>
-              <a:cs typeface="+mn-cs"/>
-            </a:endParaRPr>
-          </a:p>
-        </p:txBody>
-      </p:sp>
-      <p:pic>
-        <p:nvPicPr>
-          <p:cNvPr id="38" name="Image 4" descr="preencoded.png"/>
-          <p:cNvPicPr>
-            <a:picLocks noChangeAspect="1"/>
-          </p:cNvPicPr>
-          <p:nvPr/>
-        </p:nvPicPr>
-        <p:blipFill>
-          <a:blip r:embed="rId4"/>
-          <a:stretch>
-            <a:fillRect/>
-          </a:stretch>
-        </p:blipFill>
-        <p:spPr>
-          <a:xfrm>
-            <a:off x="6761988" y="3461004"/>
-            <a:ext cx="164592" cy="164592"/>
-          </a:xfrm>
-          <a:prstGeom prst="rect">
-            <a:avLst/>
-          </a:prstGeom>
-        </p:spPr>
-      </p:pic>
       <p:sp>
         <p:nvSpPr>
           <p:cNvPr id="41" name="Shape 34"/>

</xml_diff>